<commit_message>
vFINAL: capa sem audiencia (Sr. Jose/Eder), assuntos (automacao/IA/manutencao prescritiva) e cidade Cleveland, OH
Co-Authored-By: Claude Opus 4.8 <noreply@anthropic.com>
Claude-Session: https://claude.ai/code/session_01BgzJF97kUi64KaeE2QkgWh
</commit_message>
<xml_diff>
--- a/2026.06.28 - MULTI - DataOps na Prática IA a Serviço da Alta Gestão vFINAL.pptx
+++ b/2026.06.28 - MULTI - DataOps na Prática IA a Serviço da Alta Gestão vFINAL.pptx
@@ -3639,8 +3639,8 @@
         </p:nvSpPr>
         <p:spPr>
           <a:xfrm>
-            <a:off x="868680" y="4754880"/>
-            <a:ext cx="10607040" cy="1371600"/>
+            <a:off x="868680" y="4892040"/>
+            <a:ext cx="10607040" cy="1097280"/>
           </a:xfrm>
           <a:prstGeom prst="rect">
             <a:avLst/>
@@ -3662,40 +3662,13 @@
               </a:spcAft>
             </a:pPr>
             <a:r>
-              <a:rPr sz="1400" b="0" i="0">
-                <a:solidFill>
-                  <a:srgbClr val="627D98"/>
-                </a:solidFill>
-                <a:latin typeface="Calibri"/>
-              </a:rPr>
-              <a:t>Apresentado a:  </a:t>
-            </a:r>
-            <a:r>
-              <a:rPr sz="1400" b="1" i="0">
-                <a:solidFill>
-                  <a:srgbClr val="FFFFFF"/>
-                </a:solidFill>
-                <a:latin typeface="Calibri"/>
-              </a:rPr>
-              <a:t>Sr. José  e  Éder</a:t>
-            </a:r>
-            <a:r>
-              <a:rPr sz="1400" b="0" i="0">
-                <a:solidFill>
-                  <a:srgbClr val="627D98"/>
-                </a:solidFill>
-                <a:latin typeface="Calibri"/>
-              </a:rPr>
-              <a:t>      por  </a:t>
-            </a:r>
-            <a:r>
-              <a:rPr sz="1400" b="1" i="0">
-                <a:solidFill>
-                  <a:srgbClr val="FFFFFF"/>
-                </a:solidFill>
-                <a:latin typeface="Calibri"/>
-              </a:rPr>
-              <a:t>Itiel Gonçalves · VP Automação &amp; Elétrica</a:t>
+              <a:rPr sz="1450" b="0" i="0">
+                <a:solidFill>
+                  <a:srgbClr val="CDDAE8"/>
+                </a:solidFill>
+                <a:latin typeface="Calibri"/>
+              </a:rPr>
+              <a:t>Automação inteligente  ·  Inteligência Artificial  ·  Manutenção prescritiva</a:t>
             </a:r>
           </a:p>
           <a:p>
@@ -3708,32 +3681,13 @@
               </a:spcAft>
             </a:pPr>
             <a:r>
-              <a:rPr sz="1300" b="0" i="0">
-                <a:solidFill>
-                  <a:srgbClr val="627D98"/>
-                </a:solidFill>
-                <a:latin typeface="Calibri"/>
-              </a:rPr>
-              <a:t>Centro de Operações Integradas (COI)  ·  Benchmarking entre plantas  ·  Manutenção prescritiva</a:t>
-            </a:r>
-          </a:p>
-          <a:p>
-            <a:pPr algn="l">
-              <a:spcBef>
-                <a:spcPts val="0"/>
-              </a:spcBef>
-              <a:spcAft>
-                <a:spcPts val="400"/>
-              </a:spcAft>
-            </a:pPr>
-            <a:r>
               <a:rPr sz="1250" b="0" i="0">
                 <a:solidFill>
                   <a:srgbClr val="8FA9C2"/>
                 </a:solidFill>
                 <a:latin typeface="Calibri"/>
               </a:rPr>
-              <a:t>Base: sessão estratégica Inpasa × Rockwell  ·  Mayfield Heights, OH  ·  26/06/2026</a:t>
+              <a:t>Base: sessão estratégica Inpasa × Rockwell  ·  Cleveland, OH  ·  26/06/2026</a:t>
             </a:r>
           </a:p>
         </p:txBody>

</xml_diff>

<commit_message>
vFINAL: slide Parceria Rockwell em ingles + card 'Decisao reativa' refinado
- Slide 3 (parceria) traduzido para ingles (titulo, intro, cards, cargos), cidade Cleveland
- Slide 2 card 'Decisao reativa': TracOS cobre rotativos com insight prescritivo; faltam alarmes acima da norma e prescritivo de nao rotativos

Co-Authored-By: Claude Opus 4.8 <noreply@anthropic.com>
Claude-Session: https://claude.ai/code/session_01BgzJF97kUi64KaeE2QkgWh
</commit_message>
<xml_diff>
--- a/2026.06.28 - MULTI - DataOps na Prática IA a Serviço da Alta Gestão vFINAL.pptx
+++ b/2026.06.28 - MULTI - DataOps na Prática IA a Serviço da Alta Gestão vFINAL.pptx
@@ -14711,7 +14711,7 @@
                 </a:solidFill>
                 <a:latin typeface="Calibri"/>
               </a:rPr>
-              <a:t>Manutenção parcialmente reativa (TracOS cobre rotativos) e alarmes acima da norma — falta prescritivo e não rotativos.</a:t>
+              <a:t>Manutenção parcialmente reativa: o TracOS cobre os rotativos com insight prescritivo. Faltam os alarmes acima da norma e o prescritivo dos equipamentos não rotativos.</a:t>
             </a:r>
           </a:p>
         </p:txBody>
@@ -17650,7 +17650,7 @@
                 </a:solidFill>
                 <a:latin typeface="Calibri"/>
               </a:rPr>
-              <a:t>PARCERIA ESTRATÉGICA</a:t>
+              <a:t>STRATEGIC PARTNERSHIP</a:t>
             </a:r>
           </a:p>
         </p:txBody>
@@ -17692,7 +17692,7 @@
                 </a:solidFill>
                 <a:latin typeface="Calibri"/>
               </a:rPr>
-              <a:t>Inpasa × Rockwell — leitura da sessão de 26/06/2026</a:t>
+              <a:t>Inpasa × Rockwell — June 26, 2026 session readout</a:t>
             </a:r>
           </a:p>
         </p:txBody>
@@ -17734,7 +17734,7 @@
                 </a:solidFill>
                 <a:latin typeface="Calibri"/>
               </a:rPr>
-              <a:t>Encontro executivo no campus da Rockwell (Mayfield Heights, OH). A Inpasa apresentou seus objetivos de automação; a Rockwell trouxe a visão de COI, DataOps e IA industrial.</a:t>
+              <a:t>Executive session at Rockwell's campus (Cleveland, OH). Inpasa presented its automation goals; Rockwell shared its vision for the COI, DataOps and industrial AI.</a:t>
             </a:r>
           </a:p>
         </p:txBody>
@@ -17873,7 +17873,7 @@
                 </a:solidFill>
                 <a:latin typeface="Calibri"/>
               </a:rPr>
-              <a:t>Agenda da sessão</a:t>
+              <a:t>Session agenda</a:t>
             </a:r>
           </a:p>
         </p:txBody>
@@ -18275,7 +18275,7 @@
                 </a:solidFill>
                 <a:latin typeface="Calibri"/>
               </a:rPr>
-              <a:t>Quem participou</a:t>
+              <a:t>Attendees</a:t>
             </a:r>
           </a:p>
         </p:txBody>
@@ -18338,7 +18338,7 @@
                 </a:solidFill>
                 <a:latin typeface="Calibri"/>
               </a:rPr>
-              <a:t>— VP Automação &amp; Elétrica (Inpasa)</a:t>
+              <a:t>— VP, Automation &amp; Electrical (Inpasa)</a:t>
             </a:r>
           </a:p>
           <a:p>
@@ -18418,7 +18418,7 @@
                 </a:solidFill>
                 <a:latin typeface="Calibri"/>
               </a:rPr>
-              <a:t>— Diretor Software &amp; Control, LATAM</a:t>
+              <a:t>— Director, Software &amp; Control, LATAM</a:t>
             </a:r>
           </a:p>
           <a:p>
@@ -18458,7 +18458,7 @@
                 </a:solidFill>
                 <a:latin typeface="Calibri"/>
               </a:rPr>
-              <a:t>— Diretor Visualization &amp; Production Data</a:t>
+              <a:t>— Director, Visualization &amp; Production Data</a:t>
             </a:r>
           </a:p>
           <a:p>
@@ -18498,7 +18498,7 @@
                 </a:solidFill>
                 <a:latin typeface="Calibri"/>
               </a:rPr>
-              <a:t>— PM Controllers · Chris Stearns — PlantPAx PM</a:t>
+              <a:t>— PM, Controllers · Chris Stearns — PlantPAx PM</a:t>
             </a:r>
           </a:p>
           <a:p>
@@ -18538,7 +18538,7 @@
                 </a:solidFill>
                 <a:latin typeface="Calibri"/>
               </a:rPr>
-              <a:t>— Solution Architect (time Brasil)</a:t>
+              <a:t>— Solution Architect (Brazil team)</a:t>
             </a:r>
           </a:p>
         </p:txBody>

</xml_diff>

<commit_message>
vFINAL: slide Industrial DataOps explica siglas OT/IT/ET (legenda)
Co-Authored-By: Claude Opus 4.8 <noreply@anthropic.com>
Claude-Session: https://claude.ai/code/session_01BgzJF97kUi64KaeE2QkgWh
</commit_message>
<xml_diff>
--- a/2026.06.28 - MULTI - DataOps na Prática IA a Serviço da Alta Gestão vFINAL.pptx
+++ b/2026.06.28 - MULTI - DataOps na Prática IA a Serviço da Alta Gestão vFINAL.pptx
@@ -4012,7 +4012,7 @@
                 </a:solidFill>
                 <a:latin typeface="Calibri"/>
               </a:rPr>
-              <a:t>Em vez de integrações ponto a ponto, um hub central contextualiza e reaproveita o dado.</a:t>
+              <a:t>OT = operação (chão de fábrica) · IT = sistemas corporativos · ET = engenharia (ativos).</a:t>
             </a:r>
           </a:p>
         </p:txBody>
@@ -4131,7 +4131,7 @@
                 </a:solidFill>
                 <a:latin typeface="Calibri"/>
               </a:rPr>
-              <a:t>O hub industrial consolida dados de OT, IT e ET com contextualização, modelos, qualidade e catálogo — reutilizáveis por várias aplicações e pela IA.</a:t>
+              <a:t>Em vez de integrações ponto a ponto, o hub consolida OT, IT e ET com contextualização, modelos, qualidade e catálogo — reutilizáveis por várias aplicações e pela IA.</a:t>
             </a:r>
           </a:p>
         </p:txBody>

</xml_diff>

<commit_message>
vFINAL: corrige Optix (HMI/dados na borda, nao SCADA multi-site) + slide 11 'PlantPAx'->'sistema de supervisao'
Co-Authored-By: Claude Opus 4.8 <noreply@anthropic.com>
Claude-Session: https://claude.ai/code/session_01BgzJF97kUi64KaeE2QkgWh
</commit_message>
<xml_diff>
--- a/2026.06.28 - MULTI - DataOps na Prática IA a Serviço da Alta Gestão vFINAL.pptx
+++ b/2026.06.28 - MULTI - DataOps na Prática IA a Serviço da Alta Gestão vFINAL.pptx
@@ -10409,7 +10409,7 @@
                 </a:solidFill>
                 <a:latin typeface="Calibri"/>
               </a:rPr>
-              <a:t>Hoje o dado vive dentro de cada PlantPAx. O DataMosaix é a camada que </a:t>
+              <a:t>Hoje o dado vive dentro de cada sistema de supervisão. O DataMosaix é a camada que </a:t>
             </a:r>
             <a:r>
               <a:rPr sz="1550" b="1" i="0">
@@ -22777,7 +22777,7 @@
                 </a:solidFill>
                 <a:latin typeface="Calibri"/>
               </a:rPr>
-              <a:t> da Rockwell: HMI/SCADA cloud-enabled, projetada e implantada pelo navegador.</a:t>
+              <a:t> da Rockwell: HMI e dados na borda, cloud-enabled, projetada e implantada pelo navegador.</a:t>
             </a:r>
           </a:p>
         </p:txBody>
@@ -22916,7 +22916,7 @@
                 </a:solidFill>
                 <a:latin typeface="Calibri"/>
               </a:rPr>
-              <a:t>SCADA multi-site (Optix)</a:t>
+              <a:t>FactoryTalk Optix</a:t>
             </a:r>
           </a:p>
         </p:txBody>
@@ -22958,7 +22958,7 @@
                 </a:solidFill>
                 <a:latin typeface="Calibri"/>
               </a:rPr>
-              <a:t>O próprio FactoryTalk Optix ganha módulo SCADA: centraliza o supervisório de todas as plantas, com redundância de servidor e workstation clients.</a:t>
+              <a:t>Plataforma aberta de HMI e dados na borda (Connect, Contextualize, Visualize, Share). Roda em painel, IPC ou cliente web (Windows/Linux) — não um SCADA multi-site com redundância.</a:t>
             </a:r>
           </a:p>
         </p:txBody>

</xml_diff>